<commit_message>
DFM: keep the battery cover closed; mould the hook gap with a lifter
The pass-through window put a hole in a battery cover (cells exposed,
dust), so it is removed. The closed retention hook is kept and its
1.0 mm gap is released by a 10 deg angled lifter (5 mm travel,
~28 mm stroke):
- hook block gap face drafted 1 deg along the lifter travel (-Z)
- hook-leg roots now get R0.5 (no window rim limiting the blend)
- analysis checks every straight-pull undercut face for free travel
  over the lifter stroke: 55.8 mm2 released, 0.004 mm2 numerical left
- ejector pins kept out of the lifter zone; gate table re-argued
  without the window weld line; deck, figures and README updated

Co-Authored-By: Claude Opus 5.5 <noreply@anthropic.com>
Claude-Session: https://claude.ai/code/session_01KoxELyDSgqF2gUini1Wior
</commit_message>
<xml_diff>
--- a/output/DFM.pptx
+++ b/output/DFM.pptx
@@ -295,25 +295,25 @@
                 <c:formatCode>General</c:formatCode>
                 <c:ptCount val="9"/>
                 <c:pt idx="0">
-                  <c:v>0.3</c:v>
+                  <c:v>0.2</c:v>
                 </c:pt>
                 <c:pt idx="1">
-                  <c:v>1.6</c:v>
+                  <c:v>1.7</c:v>
                 </c:pt>
                 <c:pt idx="2">
-                  <c:v>13.9</c:v>
+                  <c:v>13.4</c:v>
                 </c:pt>
                 <c:pt idx="3">
-                  <c:v>7.3</c:v>
+                  <c:v>7.0</c:v>
                 </c:pt>
                 <c:pt idx="4">
-                  <c:v>4.5</c:v>
+                  <c:v>4.3</c:v>
                 </c:pt>
                 <c:pt idx="5">
-                  <c:v>68.9</c:v>
+                  <c:v>69.8</c:v>
                 </c:pt>
                 <c:pt idx="6">
-                  <c:v>3.5</c:v>
+                  <c:v>3.6</c:v>
                 </c:pt>
                 <c:pt idx="7">
                   <c:v>0.0</c:v>
@@ -1626,7 +1626,7 @@
           <a:lstStyle/>
           <a:p>
             <a:r>
-              <a:t>Undercut test: every face must see free space along its own release direction (+Y for A, -Y for B); vertical faces must escape either way. Lifter sized for the gap depth 4.5 mm + 0.5 mm clearance at 10 deg max lifter angle.</a:t>
+              <a:t>Undercut test: every face must see free space along its own release direction (+Y for A, -Y for B); vertical faces must escape either way. For the DFM part, each remaining undercut face is checked for free travel over the lifter stroke along -Z (relative motion of the lifter head). Lifter travel = gap depth 4.5 mm + 0.5 mm clearance at 10 deg. A pass-through window would remove the lifter but puts a hole in a battery cover, so it was rejected.</a:t>
             </a:r>
           </a:p>
         </p:txBody>
@@ -5698,7 +5698,7 @@
                 </a:solidFill>
                 <a:latin typeface="Calibri"/>
               </a:rPr>
-              <a:t>All three are fixed in part_DFM.step</a:t>
+              <a:t>Draft + radii fixed in part_DFM.step; the hook gap is moulded by a lifter (the cover stays closed)</a:t>
             </a:r>
           </a:p>
         </p:txBody>
@@ -5794,7 +5794,7 @@
                 </a:solidFill>
                 <a:latin typeface="Calibri"/>
               </a:rPr>
-              <a:t>From G3: latch and recess first, plate next, top lip and bumps last. Max flow 79 mm.</a:t>
+              <a:t>From G3: latch and recess first, plate next, top lip and bumps last. Max flow 80 mm.</a:t>
             </a:r>
           </a:p>
         </p:txBody>
@@ -6147,7 +6147,7 @@
                 </a:solidFill>
                 <a:latin typeface="Calibri"/>
               </a:rPr>
-              <a:t> 0.02 mm deep at the top corners, bump tips and hook window.</a:t>
+              <a:t> 0.02 mm deep at the top corners, bump tips and the hook gap (vent along the lifter).</a:t>
             </a:r>
           </a:p>
           <a:p>
@@ -6181,7 +6181,7 @@
                 </a:solidFill>
                 <a:latin typeface="Calibri"/>
               </a:rPr>
-              <a:t> short, just downstream of the hook window (Z 73–77), in the zone under the top lip.</a:t>
+              <a:t> none on the cosmetic face (the plate has no openings). Fronts meet only around the hook block, on the inside.</a:t>
             </a:r>
           </a:p>
           <a:p>
@@ -7222,7 +7222,7 @@
                 </a:solidFill>
                 <a:latin typeface="Calibri"/>
               </a:rPr>
-              <a:t>Straight-pull, 2-plate, 4-cavity tool: no lifters or sliders, every wall drafted, every internal corner radiused.</a:t>
+              <a:t>2-plate, 4-cavity tool with one lifter per cavity: closed cover, every wall drafted, every internal corner radiused.</a:t>
             </a:r>
           </a:p>
         </p:txBody>
@@ -7925,7 +7925,7 @@
                           </a:solidFill>
                           <a:latin typeface="Calibri"/>
                         </a:rPr>
-                        <a:t>1° core · 3° cavity · 3° shut-off</a:t>
+                        <a:t>1° core · 3° cavity · 1° lifter gap</a:t>
                       </a:r>
                     </a:p>
                   </a:txBody>
@@ -7950,7 +7950,7 @@
                           </a:solidFill>
                           <a:latin typeface="Calibri"/>
                         </a:rPr>
-                        <a:t>Undercut</a:t>
+                        <a:t>Hook undercut</a:t>
                       </a:r>
                     </a:p>
                   </a:txBody>
@@ -7973,7 +7973,7 @@
                           </a:solidFill>
                           <a:latin typeface="Calibri"/>
                         </a:rPr>
-                        <a:t>57 mm² → lifter</a:t>
+                        <a:t>57 mm², no release defined</a:t>
                       </a:r>
                     </a:p>
                   </a:txBody>
@@ -7996,7 +7996,7 @@
                           </a:solidFill>
                           <a:latin typeface="Calibri"/>
                         </a:rPr>
-                        <a:t>0 → pass-through window 6 × 4.5</a:t>
+                        <a:t>closed hook kept; 10° lifter, gap face 1° drafted</a:t>
                       </a:r>
                     </a:p>
                   </a:txBody>
@@ -8351,7 +8351,7 @@
                           </a:solidFill>
                           <a:latin typeface="Calibri"/>
                         </a:rPr>
-                        <a:t>4.49 cm³ · 4.72 g</a:t>
+                        <a:t>4.55 cm³ · 4.78 g</a:t>
                       </a:r>
                     </a:p>
                   </a:txBody>
@@ -8490,7 +8490,7 @@
                 </a:solidFill>
                 <a:latin typeface="Calibri"/>
               </a:rPr>
-              <a:t>Window visibility:</a:t>
+              <a:t>Lifter:</a:t>
             </a:r>
             <a:r>
               <a:rPr sz="1100">
@@ -8499,7 +8499,7 @@
                 </a:solidFill>
                 <a:latin typeface="Calibri"/>
               </a:rPr>
-              <a:t> confirm with the rear-case lip, or revert to the closed hook plus a lifter.</a:t>
+              <a:t> confirm ≥ 30 mm ejector stroke and rod clearance in the 4-cavity layout.</a:t>
             </a:r>
           </a:p>
           <a:p>
@@ -8524,7 +8524,7 @@
                 </a:solidFill>
                 <a:latin typeface="Calibri"/>
               </a:rPr>
-              <a:t>Hook-leg side roots:</a:t>
+              <a:t>Rear case:</a:t>
             </a:r>
             <a:r>
               <a:rPr sz="1100">
@@ -8533,7 +8533,7 @@
                 </a:solidFill>
                 <a:latin typeface="Calibri"/>
               </a:rPr>
-              <a:t> 4 short edges left sharp (blend cannot close on the shut-off rim). Add R0.3 in native CAD.</a:t>
+              <a:t> check the 1.0 mm hook gap (now opening 1° toward −Z) against the housing edge.</a:t>
             </a:r>
           </a:p>
         </p:txBody>
@@ -8720,7 +8720,7 @@
                 </a:solidFill>
                 <a:latin typeface="Calibri"/>
               </a:rPr>
-              <a:t>Flat PL on the outer-face edge; one 7 mm step around the snap latch. No side actions.</a:t>
+              <a:t>Flat PL on the outer-face edge; one 7 mm step around the snap latch. One lifter per cavity for the hook.</a:t>
             </a:r>
           </a:p>
         </p:txBody>
@@ -9156,7 +9156,7 @@
                 </a:solidFill>
                 <a:latin typeface="Calibri"/>
               </a:rPr>
-              <a:t>Hook:</a:t>
+              <a:t>Hook gap (purple):</a:t>
             </a:r>
             <a:r>
               <a:rPr sz="1200">
@@ -9165,7 +9165,7 @@
                 </a:solidFill>
                 <a:latin typeface="Calibri"/>
               </a:rPr>
-              <a:t> local 3° shut-off through the new window, not a lifter.</a:t>
+              <a:t> moulded by a 10° angled lifter on the B side. No hole in the cover.</a:t>
             </a:r>
           </a:p>
           <a:p>
@@ -9190,7 +9190,7 @@
                 </a:solidFill>
                 <a:latin typeface="Calibri"/>
               </a:rPr>
-              <a:t>422 PL edges</a:t>
+              <a:t>400 PL edges</a:t>
             </a:r>
             <a:r>
               <a:rPr sz="1200">
@@ -9295,7 +9295,7 @@
                 </a:solidFill>
                 <a:latin typeface="Calibri"/>
               </a:rPr>
-              <a:t>As received: every wall at 0°. DFM: 1° core side, 3° cavity side and shut-off.</a:t>
+              <a:t>As received: every wall at 0°. DFM: 1° core side, 3° cavity side, 1° on the lifter-formed hook gap.</a:t>
             </a:r>
           </a:p>
         </p:txBody>
@@ -9602,7 +9602,7 @@
                           </a:solidFill>
                           <a:latin typeface="Calibri"/>
                         </a:rPr>
-                        <a:t>0.3 mm²</a:t>
+                        <a:t>2.5 mm²</a:t>
                       </a:r>
                     </a:p>
                   </a:txBody>
@@ -9673,7 +9673,7 @@
                           </a:solidFill>
                           <a:latin typeface="Calibri"/>
                         </a:rPr>
-                        <a:t>1,206</a:t>
+                        <a:t>1,195</a:t>
                       </a:r>
                     </a:p>
                   </a:txBody>
@@ -9744,7 +9744,7 @@
                           </a:solidFill>
                           <a:latin typeface="Calibri"/>
                         </a:rPr>
-                        <a:t>77</a:t>
+                        <a:t>36</a:t>
                       </a:r>
                     </a:p>
                   </a:txBody>
@@ -9815,7 +9815,7 @@
                           </a:solidFill>
                           <a:latin typeface="Calibri"/>
                         </a:rPr>
-                        <a:t>406</a:t>
+                        <a:t>414</a:t>
                       </a:r>
                     </a:p>
                   </a:txBody>
@@ -9886,7 +9886,7 @@
                           </a:solidFill>
                           <a:latin typeface="Calibri"/>
                         </a:rPr>
-                        <a:t>3,824</a:t>
+                        <a:t>3,876</a:t>
                       </a:r>
                     </a:p>
                   </a:txBody>
@@ -10012,7 +10012,7 @@
                 </a:solidFill>
                 <a:latin typeface="Calibri"/>
               </a:rPr>
-              <a:t>PL and shut-off edges stay sharp.</a:t>
+              <a:t>PL edges stay sharp.</a:t>
             </a:r>
             <a:r>
               <a:rPr sz="1200">
@@ -10046,7 +10046,7 @@
                 </a:solidFill>
                 <a:latin typeface="Calibri"/>
               </a:rPr>
-              <a:t>Remaining &lt; 1 mm²</a:t>
+              <a:t>Remaining 2.5 mm²</a:t>
             </a:r>
             <a:r>
               <a:rPr sz="1200">
@@ -10055,7 +10055,7 @@
                 </a:solidFill>
                 <a:latin typeface="Calibri"/>
               </a:rPr>
-              <a:t> are fillet end-caps (tessellation slivers), not moulded walls.</a:t>
+              <a:t> are the two hook-leg end faces at the lifter head. The lifter pulls away normal to them, so they need no draft.</a:t>
             </a:r>
           </a:p>
         </p:txBody>
@@ -10151,7 +10151,7 @@
                 </a:solidFill>
                 <a:latin typeface="Calibri"/>
               </a:rPr>
-              <a:t>A 1.0 mm gap behind the hook block is shadowed by the plate: 57 mm² of undercut.</a:t>
+              <a:t>The 1.0 mm hook gap cannot be pulled straight. The cover must stay closed, so the tool uses a lifter.</a:t>
             </a:r>
           </a:p>
         </p:txBody>
@@ -10483,7 +10483,7 @@
                           </a:solidFill>
                           <a:latin typeface="Calibri"/>
                         </a:rPr>
-                        <a:t>10°, 5.0 mm travel → 28 mm stroke</a:t>
+                        <a:t>10°, 5.0 mm travel in −Z → 28 mm ejector stroke</a:t>
                       </a:r>
                     </a:p>
                   </a:txBody>
@@ -10506,7 +10506,7 @@
                           </a:solidFill>
                           <a:latin typeface="Calibri"/>
                         </a:rPr>
-                        <a:t>none</a:t>
+                        <a:t>none: cover stays closed</a:t>
                       </a:r>
                     </a:p>
                   </a:txBody>
@@ -10523,13 +10523,13 @@
                     <a:p>
                       <a:pPr algn="ctr"/>
                       <a:r>
-                        <a:rPr sz="1000" b="0">
-                          <a:solidFill>
-                            <a:srgbClr val="1F2A36"/>
-                          </a:solidFill>
-                          <a:latin typeface="Calibri"/>
-                        </a:rPr>
-                        <a:t>costly, wear</a:t>
+                        <a:rPr sz="1000" b="1">
+                          <a:solidFill>
+                            <a:srgbClr val="2E8B57"/>
+                          </a:solidFill>
+                          <a:latin typeface="Calibri"/>
+                        </a:rPr>
+                        <a:t>SELECTED</a:t>
                       </a:r>
                     </a:p>
                   </a:txBody>
@@ -10648,7 +10648,7 @@
                           </a:solidFill>
                           <a:latin typeface="Calibri"/>
                         </a:rPr>
-                        <a:t>Pass-through window</a:t>
+                        <a:t>Window through plate</a:t>
                       </a:r>
                     </a:p>
                   </a:txBody>
@@ -10671,7 +10671,7 @@
                           </a:solidFill>
                           <a:latin typeface="Calibri"/>
                         </a:rPr>
-                        <a:t>A steel through a 6.0 × 4.5 window, 3° shut-off</a:t>
+                        <a:t>cavity steel through the plate</a:t>
                       </a:r>
                     </a:p>
                   </a:txBody>
@@ -10694,7 +10694,7 @@
                           </a:solidFill>
                           <a:latin typeface="Calibri"/>
                         </a:rPr>
-                        <a:t>hole in the outer face at the hook</a:t>
+                        <a:t>hole in a battery cover: cells exposed, dust</a:t>
                       </a:r>
                     </a:p>
                   </a:txBody>
@@ -10713,11 +10713,11 @@
                       <a:r>
                         <a:rPr sz="1000" b="1">
                           <a:solidFill>
-                            <a:srgbClr val="2E8B57"/>
-                          </a:solidFill>
-                          <a:latin typeface="Calibri"/>
-                        </a:rPr>
-                        <a:t>SELECTED</a:t>
+                            <a:srgbClr val="D62728"/>
+                          </a:solidFill>
+                          <a:latin typeface="Calibri"/>
+                        </a:rPr>
+                        <a:t>rejected</a:t>
                       </a:r>
                     </a:p>
                   </a:txBody>
@@ -10797,7 +10797,7 @@
                 </a:solidFill>
                 <a:latin typeface="Calibri"/>
               </a:rPr>
-              <a:t>undercut, as received</a:t>
+              <a:t>undercut, no release (as received)</a:t>
             </a:r>
           </a:p>
         </p:txBody>
@@ -10832,7 +10832,7 @@
                 </a:solidFill>
                 <a:latin typeface="Cambria"/>
               </a:rPr>
-              <a:t>≈ 0 mm²</a:t>
+              <a:t>56 mm²</a:t>
             </a:r>
           </a:p>
         </p:txBody>
@@ -10867,7 +10867,7 @@
                 </a:solidFill>
                 <a:latin typeface="Calibri"/>
               </a:rPr>
-              <a:t>after (0.04 mm² numerical slivers)</a:t>
+              <a:t>released by the lifter  ·  0.004 mm² left</a:t>
             </a:r>
           </a:p>
         </p:txBody>
@@ -10880,8 +10880,8 @@
         </p:nvSpPr>
         <p:spPr>
           <a:xfrm>
-            <a:off x="7589520" y="5349240"/>
-            <a:ext cx="4160520" cy="914400"/>
+            <a:off x="7589520" y="5257800"/>
+            <a:ext cx="4160520" cy="1097280"/>
           </a:xfrm>
           <a:prstGeom prst="rect">
             <a:avLst/>
@@ -10902,7 +10902,7 @@
                 </a:solidFill>
                 <a:latin typeface="Calibri"/>
               </a:rPr>
-              <a:t>Check with the rear case: </a:t>
+              <a:t>Lifter concept: </a:t>
             </a:r>
             <a:r>
               <a:rPr sz="1100" b="0" i="0">
@@ -10911,7 +10911,7 @@
                 </a:solidFill>
                 <a:latin typeface="Calibri"/>
               </a:rPr>
-              <a:t>the window sits at the hook end of the cover. If it has to stay invisible, keep the closed hook and budget the lifter instead.</a:t>
+              <a:t>L-shaped head fills the gap from the −Z side. The rod stands in front of the hook block, so it clears the block at 10°. The gap face on the block opens 1° toward −Z. Needs a mould base with ≥ 30 mm ejector stroke.</a:t>
             </a:r>
           </a:p>
         </p:txBody>
@@ -11007,7 +11007,7 @@
                 </a:solidFill>
                 <a:latin typeface="Calibri"/>
               </a:rPr>
-              <a:t>Nominal wall held at a uniform 2.0 mm; ribs at 50 % of wall. No thick nodes (max 2.31 mm).</a:t>
+              <a:t>Nominal wall held at a uniform 2.0 mm; ribs at 50 % of wall. No thick nodes (max 2.32 mm).</a:t>
             </a:r>
           </a:p>
         </p:txBody>
@@ -11332,7 +11332,7 @@
                           </a:solidFill>
                           <a:latin typeface="Calibri"/>
                         </a:rPr>
-                        <a:t>0.72</a:t>
+                        <a:t>0.74</a:t>
                       </a:r>
                     </a:p>
                   </a:txBody>
@@ -11474,7 +11474,7 @@
                           </a:solidFill>
                           <a:latin typeface="Calibri"/>
                         </a:rPr>
-                        <a:t>2.31</a:t>
+                        <a:t>2.32</a:t>
                       </a:r>
                     </a:p>
                   </a:txBody>
@@ -11810,7 +11810,7 @@
                 </a:solidFill>
                 <a:latin typeface="Calibri"/>
               </a:rPr>
-              <a:t>Tunnel gate at the latch end: gate mark hidden, the snap arm fills first, weld line under the top lip.</a:t>
+              <a:t>Tunnel gate at the latch end: gate mark hidden, the snap arm fills first, no weld line on the cosmetic face.</a:t>
             </a:r>
           </a:p>
         </p:txBody>
@@ -12119,7 +12119,7 @@
                           </a:solidFill>
                           <a:latin typeface="Calibri"/>
                         </a:rPr>
-                        <a:t>Weld line</a:t>
+                        <a:t>Fill behaviour</a:t>
                       </a:r>
                     </a:p>
                   </a:txBody>
@@ -12259,7 +12259,7 @@
                           </a:solidFill>
                           <a:latin typeface="Calibri"/>
                         </a:rPr>
-                        <a:t>hidden</a:t>
+                        <a:t>hidden (top end)</a:t>
                       </a:r>
                     </a:p>
                   </a:txBody>
@@ -12282,7 +12282,7 @@
                           </a:solidFill>
                           <a:latin typeface="Calibri"/>
                         </a:rPr>
-                        <a:t>centre of cosmetic face</a:t>
+                        <a:t>snap latch fills last</a:t>
                       </a:r>
                     </a:p>
                   </a:txBody>
@@ -12422,7 +12422,7 @@
                           </a:solidFill>
                           <a:latin typeface="Calibri"/>
                         </a:rPr>
-                        <a:t>side wall</a:t>
+                        <a:t>visible side wall</a:t>
                       </a:r>
                     </a:p>
                   </a:txBody>
@@ -12445,7 +12445,7 @@
                           </a:solidFill>
                           <a:latin typeface="Calibri"/>
                         </a:rPr>
-                        <a:t>across cosmetic face</a:t>
+                        <a:t>flow splits at recess</a:t>
                       </a:r>
                     </a:p>
                   </a:txBody>
@@ -12539,7 +12539,7 @@
                           </a:solidFill>
                           <a:latin typeface="Calibri"/>
                         </a:rPr>
-                        <a:t>79 mm</a:t>
+                        <a:t>80 mm</a:t>
                       </a:r>
                     </a:p>
                   </a:txBody>
@@ -12608,7 +12608,7 @@
                           </a:solidFill>
                           <a:latin typeface="Calibri"/>
                         </a:rPr>
-                        <a:t>under top lip (Z 73–77)</a:t>
+                        <a:t>snap latch fills first</a:t>
                       </a:r>
                     </a:p>
                   </a:txBody>
@@ -12702,7 +12702,7 @@
                           </a:solidFill>
                           <a:latin typeface="Calibri"/>
                         </a:rPr>
-                        <a:t>54 mm</a:t>
+                        <a:t>58 mm</a:t>
                       </a:r>
                     </a:p>
                   </a:txBody>
@@ -12725,7 +12725,7 @@
                           </a:solidFill>
                           <a:latin typeface="Calibri"/>
                         </a:rPr>
-                        <a:t>27</a:t>
+                        <a:t>29</a:t>
                       </a:r>
                     </a:p>
                   </a:txBody>
@@ -12771,7 +12771,7 @@
                           </a:solidFill>
                           <a:latin typeface="Calibri"/>
                         </a:rPr>
-                        <a:t>above window</a:t>
+                        <a:t>3-plate tool cost</a:t>
                       </a:r>
                     </a:p>
                   </a:txBody>
@@ -12788,13 +12788,13 @@
                     <a:p>
                       <a:pPr algn="ctr"/>
                       <a:r>
-                        <a:rPr sz="1000" b="0">
-                          <a:solidFill>
-                            <a:srgbClr val="1F2A36"/>
-                          </a:solidFill>
-                          <a:latin typeface="Calibri"/>
-                        </a:rPr>
-                        <a:t>cost</a:t>
+                        <a:rPr sz="1000" b="1">
+                          <a:solidFill>
+                            <a:srgbClr val="D62728"/>
+                          </a:solidFill>
+                          <a:latin typeface="Calibri"/>
+                        </a:rPr>
+                        <a:t>reject</a:t>
                       </a:r>
                     </a:p>
                   </a:txBody>
@@ -13069,7 +13069,7 @@
                 </a:solidFill>
                 <a:latin typeface="Calibri"/>
               </a:rPr>
-              <a:t>Why not G2 / G4:</a:t>
+              <a:t>Why not the others:</a:t>
             </a:r>
             <a:r>
               <a:rPr sz="1200">
@@ -13078,7 +13078,7 @@
                 </a:solidFill>
                 <a:latin typeface="Calibri"/>
               </a:rPr>
-              <a:t> shorter flow, but the weld line crosses the cosmetic face or needs a 3-plate tool.</a:t>
+              <a:t> G1 fills the snap latch last (short-shot and air-trap risk on the critical feature). G2 leaves a visible gate mark. G4 needs a 3-plate tool.</a:t>
             </a:r>
           </a:p>
         </p:txBody>
@@ -13174,7 +13174,7 @@
                 </a:solidFill>
                 <a:latin typeface="Calibri"/>
               </a:rPr>
-              <a:t>11 round pins on flat B-side faces. With 1° draft, the part releases without scuffing the ribs.</a:t>
+              <a:t>10 round pins on flat B-side faces. With 1° draft, the part releases without scuffing the ribs.</a:t>
             </a:r>
           </a:p>
         </p:txBody>
@@ -13337,7 +13337,7 @@
         </p:nvGraphicFramePr>
         <p:xfrm>
           <a:off x="8321040" y="1463040"/>
-          <a:ext cx="3429000" cy="2962656"/>
+          <a:ext cx="3429000" cy="2715768"/>
         </p:xfrm>
         <a:graphic>
           <a:graphicData uri="http://schemas.openxmlformats.org/drawingml/2006/table">
@@ -13952,7 +13952,7 @@
                           </a:solidFill>
                           <a:latin typeface="Calibri"/>
                         </a:rPr>
-                        <a:t>X 15.5  Z 64.0</a:t>
+                        <a:t>X 27.4  Z 22.0</a:t>
                       </a:r>
                     </a:p>
                   </a:txBody>
@@ -14046,7 +14046,7 @@
                           </a:solidFill>
                           <a:latin typeface="Calibri"/>
                         </a:rPr>
-                        <a:t>X 27.4  Z 22.0</a:t>
+                        <a:t>X 27.4  Z 44.0</a:t>
                       </a:r>
                     </a:p>
                   </a:txBody>
@@ -14140,7 +14140,7 @@
                           </a:solidFill>
                           <a:latin typeface="Calibri"/>
                         </a:rPr>
-                        <a:t>X 27.4  Z 44.0</a:t>
+                        <a:t>X 27.4  Z 64.0</a:t>
                       </a:r>
                     </a:p>
                   </a:txBody>
@@ -14234,7 +14234,7 @@
                           </a:solidFill>
                           <a:latin typeface="Calibri"/>
                         </a:rPr>
-                        <a:t>X 27.4  Z 64.0</a:t>
+                        <a:t>X 15.5  Z 70.8</a:t>
                       </a:r>
                     </a:p>
                   </a:txBody>
@@ -14257,7 +14257,7 @@
                           </a:solidFill>
                           <a:latin typeface="Calibri"/>
                         </a:rPr>
-                        <a:t>plate inner face</a:t>
+                        <a:t>hook block</a:t>
                       </a:r>
                     </a:p>
                   </a:txBody>
@@ -14280,7 +14280,7 @@
                           </a:solidFill>
                           <a:latin typeface="Calibri"/>
                         </a:rPr>
-                        <a:t>Ø3</a:t>
+                        <a:t>Ø2</a:t>
                       </a:r>
                     </a:p>
                   </a:txBody>
@@ -14328,7 +14328,7 @@
                           </a:solidFill>
                           <a:latin typeface="Calibri"/>
                         </a:rPr>
-                        <a:t>X 15.5  Z 70.8</a:t>
+                        <a:t>X 15.5  Z 9.0</a:t>
                       </a:r>
                     </a:p>
                   </a:txBody>
@@ -14351,7 +14351,7 @@
                           </a:solidFill>
                           <a:latin typeface="Calibri"/>
                         </a:rPr>
-                        <a:t>hook block</a:t>
+                        <a:t>latch arm (inner face)</a:t>
                       </a:r>
                     </a:p>
                   </a:txBody>
@@ -14381,100 +14381,6 @@
                   <a:tcPr marL="54864" marR="54864" marT="18288" marB="18288" anchor="ctr">
                     <a:solidFill>
                       <a:srgbClr val="F3F5F8"/>
-                    </a:solidFill>
-                  </a:tcPr>
-                </a:tc>
-              </a:tr>
-              <a:tr h="246888">
-                <a:tc>
-                  <a:txBody>
-                    <a:bodyPr wrap="square"/>
-                    <a:lstStyle/>
-                    <a:p>
-                      <a:pPr algn="l"/>
-                      <a:r>
-                        <a:rPr sz="900" b="0">
-                          <a:solidFill>
-                            <a:srgbClr val="1F2A36"/>
-                          </a:solidFill>
-                          <a:latin typeface="Calibri"/>
-                        </a:rPr>
-                        <a:t>11</a:t>
-                      </a:r>
-                    </a:p>
-                  </a:txBody>
-                  <a:tcPr marL="54864" marR="54864" marT="18288" marB="18288" anchor="ctr">
-                    <a:solidFill>
-                      <a:srgbClr val="FFFFFF"/>
-                    </a:solidFill>
-                  </a:tcPr>
-                </a:tc>
-                <a:tc>
-                  <a:txBody>
-                    <a:bodyPr wrap="square"/>
-                    <a:lstStyle/>
-                    <a:p>
-                      <a:pPr algn="ctr"/>
-                      <a:r>
-                        <a:rPr sz="900" b="0">
-                          <a:solidFill>
-                            <a:srgbClr val="1F2A36"/>
-                          </a:solidFill>
-                          <a:latin typeface="Calibri"/>
-                        </a:rPr>
-                        <a:t>X 15.5  Z 9.0</a:t>
-                      </a:r>
-                    </a:p>
-                  </a:txBody>
-                  <a:tcPr marL="54864" marR="54864" marT="18288" marB="18288" anchor="ctr">
-                    <a:solidFill>
-                      <a:srgbClr val="FFFFFF"/>
-                    </a:solidFill>
-                  </a:tcPr>
-                </a:tc>
-                <a:tc>
-                  <a:txBody>
-                    <a:bodyPr wrap="square"/>
-                    <a:lstStyle/>
-                    <a:p>
-                      <a:pPr algn="ctr"/>
-                      <a:r>
-                        <a:rPr sz="900" b="0">
-                          <a:solidFill>
-                            <a:srgbClr val="1F2A36"/>
-                          </a:solidFill>
-                          <a:latin typeface="Calibri"/>
-                        </a:rPr>
-                        <a:t>latch arm (inner face)</a:t>
-                      </a:r>
-                    </a:p>
-                  </a:txBody>
-                  <a:tcPr marL="54864" marR="54864" marT="18288" marB="18288" anchor="ctr">
-                    <a:solidFill>
-                      <a:srgbClr val="FFFFFF"/>
-                    </a:solidFill>
-                  </a:tcPr>
-                </a:tc>
-                <a:tc>
-                  <a:txBody>
-                    <a:bodyPr wrap="square"/>
-                    <a:lstStyle/>
-                    <a:p>
-                      <a:pPr algn="ctr"/>
-                      <a:r>
-                        <a:rPr sz="900" b="0">
-                          <a:solidFill>
-                            <a:srgbClr val="1F2A36"/>
-                          </a:solidFill>
-                          <a:latin typeface="Calibri"/>
-                        </a:rPr>
-                        <a:t>Ø2</a:t>
-                      </a:r>
-                    </a:p>
-                  </a:txBody>
-                  <a:tcPr marL="54864" marR="54864" marT="18288" marB="18288" anchor="ctr">
-                    <a:solidFill>
-                      <a:srgbClr val="FFFFFF"/>
                     </a:solidFill>
                   </a:tcPr>
                 </a:tc>
@@ -14513,7 +14419,7 @@
                 </a:solidFill>
                 <a:latin typeface="Cambria"/>
               </a:rPr>
-              <a:t>11 pins</a:t>
+              <a:t>10 pins</a:t>
             </a:r>
           </a:p>
         </p:txBody>
@@ -14548,7 +14454,7 @@
                 </a:solidFill>
                 <a:latin typeface="Calibri"/>
               </a:rPr>
-              <a:t>9 × Ø3 plate · 2 × Ø2 hook / latch</a:t>
+              <a:t>8 × Ø3 plate · 2 × Ø2 hook / latch</a:t>
             </a:r>
           </a:p>
         </p:txBody>
@@ -14692,6 +14598,31 @@
                 <a:latin typeface="Calibri"/>
               </a:rPr>
               <a:t>Ø2 pin on the latch arm stops the catch from dragging.</a:t>
+            </a:r>
+          </a:p>
+          <a:p>
+            <a:pPr>
+              <a:spcAft>
+                <a:spcPts val="500"/>
+              </a:spcAft>
+            </a:pPr>
+            <a:r>
+              <a:rPr sz="1100">
+                <a:solidFill>
+                  <a:srgbClr val="F28E2B"/>
+                </a:solidFill>
+                <a:latin typeface="Calibri"/>
+              </a:rPr>
+              <a:t>▸  </a:t>
+            </a:r>
+            <a:r>
+              <a:rPr sz="1100" b="0">
+                <a:solidFill>
+                  <a:srgbClr val="1F2A36"/>
+                </a:solidFill>
+                <a:latin typeface="Calibri"/>
+              </a:rPr>
+              <a:t>The lifter pushes the hook end, so no pin sits in its zone.</a:t>
             </a:r>
           </a:p>
         </p:txBody>
@@ -14787,7 +14718,7 @@
                 </a:solidFill>
                 <a:latin typeface="Calibri"/>
               </a:rPr>
-              <a:t>4 cavities: 42 t calculated clamp → 50 t machine, 22 g shot, 842 parts/h.</a:t>
+              <a:t>4 cavities: 43 t calculated clamp → 50 t machine, 22 g shot, 842 parts/h.</a:t>
             </a:r>
           </a:p>
         </p:txBody>
@@ -15143,7 +15074,7 @@
                           </a:solidFill>
                           <a:latin typeface="Calibri"/>
                         </a:rPr>
-                        <a:t>21.6 cm²</a:t>
+                        <a:t>21.9 cm²</a:t>
                       </a:r>
                     </a:p>
                   </a:txBody>
@@ -15166,7 +15097,7 @@
                           </a:solidFill>
                           <a:latin typeface="Calibri"/>
                         </a:rPr>
-                        <a:t>10.6 t</a:t>
+                        <a:t>10.7 t</a:t>
                       </a:r>
                     </a:p>
                   </a:txBody>
@@ -15212,7 +15143,7 @@
                           </a:solidFill>
                           <a:latin typeface="Calibri"/>
                         </a:rPr>
-                        <a:t>5.5 g</a:t>
+                        <a:t>5.6 g</a:t>
                       </a:r>
                     </a:p>
                   </a:txBody>
@@ -15283,7 +15214,7 @@
                           </a:solidFill>
                           <a:latin typeface="Calibri"/>
                         </a:rPr>
-                        <a:t>43.3 cm²</a:t>
+                        <a:t>43.8 cm²</a:t>
                       </a:r>
                     </a:p>
                   </a:txBody>
@@ -15306,7 +15237,7 @@
                           </a:solidFill>
                           <a:latin typeface="Calibri"/>
                         </a:rPr>
-                        <a:t>21.2 t</a:t>
+                        <a:t>21.5 t</a:t>
                       </a:r>
                     </a:p>
                   </a:txBody>
@@ -15352,7 +15283,7 @@
                           </a:solidFill>
                           <a:latin typeface="Calibri"/>
                         </a:rPr>
-                        <a:t>11.0 g</a:t>
+                        <a:t>11.2 g</a:t>
                       </a:r>
                     </a:p>
                   </a:txBody>
@@ -15423,7 +15354,7 @@
                           </a:solidFill>
                           <a:latin typeface="Calibri"/>
                         </a:rPr>
-                        <a:t>86.6 cm²</a:t>
+                        <a:t>87.7 cm²</a:t>
                       </a:r>
                     </a:p>
                   </a:txBody>
@@ -15446,7 +15377,7 @@
                           </a:solidFill>
                           <a:latin typeface="Calibri"/>
                         </a:rPr>
-                        <a:t>42.4 t</a:t>
+                        <a:t>42.9 t</a:t>
                       </a:r>
                     </a:p>
                   </a:txBody>
@@ -15492,7 +15423,7 @@
                           </a:solidFill>
                           <a:latin typeface="Calibri"/>
                         </a:rPr>
-                        <a:t>22.1 g</a:t>
+                        <a:t>22.3 g</a:t>
                       </a:r>
                     </a:p>
                   </a:txBody>
@@ -15563,7 +15494,7 @@
                           </a:solidFill>
                           <a:latin typeface="Calibri"/>
                         </a:rPr>
-                        <a:t>173.2 cm²</a:t>
+                        <a:t>175.4 cm²</a:t>
                       </a:r>
                     </a:p>
                   </a:txBody>
@@ -15586,7 +15517,7 @@
                           </a:solidFill>
                           <a:latin typeface="Calibri"/>
                         </a:rPr>
-                        <a:t>84.7 t</a:t>
+                        <a:t>85.8 t</a:t>
                       </a:r>
                     </a:p>
                   </a:txBody>
@@ -15632,7 +15563,7 @@
                           </a:solidFill>
                           <a:latin typeface="Calibri"/>
                         </a:rPr>
-                        <a:t>44.1 g</a:t>
+                        <a:t>44.6 g</a:t>
                       </a:r>
                     </a:p>
                   </a:txBody>
@@ -15812,7 +15743,7 @@
                 </a:solidFill>
                 <a:latin typeface="Calibri"/>
               </a:rPr>
-              <a:t>A_part = 20.65 cm² (measured)  ·  A_runner ≈ 1.0 cm²/cavity  ·  p = 40 MPa (ABS, 2 mm wall)  ·  SF = 1.2</a:t>
+              <a:t>A_part = 20.92 cm² (measured)  ·  A_runner ≈ 1.0 cm²/cavity  ·  p = 40 MPa (ABS, 2 mm wall)  ·  SF = 1.2</a:t>
             </a:r>
           </a:p>
         </p:txBody>
@@ -16392,7 +16323,7 @@
                 </a:solidFill>
                 <a:latin typeface="Cambria"/>
               </a:rPr>
-              <a:t>Re 17,163</a:t>
+              <a:t>Re 17,318</a:t>
             </a:r>
           </a:p>
         </p:txBody>
@@ -16632,7 +16563,7 @@
                 </a:solidFill>
                 <a:latin typeface="Calibri"/>
               </a:rPr>
-              <a:t> 626 W → 4.6 L/min total for a 2 K water rise.</a:t>
+              <a:t> 631 W → 4.6 L/min total for a 2 K water rise.</a:t>
             </a:r>
           </a:p>
           <a:p>

</xml_diff>